<commit_message>
Make the agenda slides customer facing
They showed a running clock, which is a presenter's tool and reads oddly in
front of a customer or an SAP account team. The clock column is gone and
each section now carries a plain duration in minutes.

Minutes come from the validated per-slide run sheets by largest-remainder
rounding, so the split stays faithful to the real timings and still totals
exactly 20, asserted at build time. The precise seconds live where they
belong, in the speaker notes.

Columns rebalanced now that a column has gone, and the footer badge reads
20 MINUTES rather than 20:00.

Co-Authored-By: Claude Opus 5 <noreply@anthropic.com>
Claude-Session: https://claude.ai/code/session_01QVxFLMr5QhjAe5cSM3jDsE
</commit_message>
<xml_diff>
--- a/agenda/INK_IT_GCC_Agenda_Slide.pptx
+++ b/agenda/INK_IT_GCC_Agenda_Slide.pptx
@@ -502,7 +502,7 @@
           <a:p>
             <a:r>
               <a:rPr lang="en-US" dirty="0"/>
-              <a:t>Twenty seconds on this slide. Say the three things they are getting: the problem, the application running, and what it costs to stand up. Tell them the API question gets answered before they have to ask it. If you are running late, compress healthcare and BTP services. Never compress the walkthrough.</a:t>
+              <a:t>Twenty seconds on this slide. Say the three things they are getting: the problem, the application running, and what it costs to stand up. Tell them the API question gets answered before they have to ask it. Your own timings: 0:40, 2:00, 2:20, 3:40, 2:20, 3:30, 3:30, 2:00. If you are running late, compress healthcare and BTP services. Never compress the walkthrough.</a:t>
             </a:r>
             <a:endParaRPr lang="en-US" dirty="0"/>
           </a:p>
@@ -986,7 +986,7 @@
                 <a:ea typeface="Calibri" pitchFamily="34" charset="-122"/>
                 <a:cs typeface="Calibri" pitchFamily="34" charset="-120"/>
               </a:rPr>
-              <a:t>The clock on the right is where you should be by the end of each section. Protect the walkthrough, it is the part that sells.</a:t>
+              <a:t>What we will walk through, and roughly how long we will spend on each part. Questions are welcome as we go.</a:t>
             </a:r>
             <a:endParaRPr lang="en-US" sz="1300" dirty="0"/>
           </a:p>
@@ -1000,20 +1000,20 @@
         </p:nvSpPr>
         <p:spPr>
           <a:xfrm>
-            <a:off x="1572768" y="1591056"/>
-            <a:ext cx="4023360" cy="182880"/>
-          </a:xfrm>
-          <a:prstGeom prst="rect">
-            <a:avLst/>
-          </a:prstGeom>
-          <a:noFill/>
-          <a:ln/>
-        </p:spPr>
-        <p:txBody>
-          <a:bodyPr wrap="square" lIns="0" tIns="0" rIns="0" bIns="0" rtlCol="0" anchor="ctr"/>
-          <a:lstStyle/>
-          <a:p>
-            <a:pPr algn="l" indent="0" marL="0">
+            <a:off x="676656" y="1591056"/>
+            <a:ext cx="749808" cy="182880"/>
+          </a:xfrm>
+          <a:prstGeom prst="rect">
+            <a:avLst/>
+          </a:prstGeom>
+          <a:noFill/>
+          <a:ln/>
+        </p:spPr>
+        <p:txBody>
+          <a:bodyPr wrap="square" lIns="0" tIns="0" rIns="0" bIns="0" rtlCol="0" anchor="ctr"/>
+          <a:lstStyle/>
+          <a:p>
+            <a:pPr algn="ctr" indent="0" marL="0">
               <a:buNone/>
             </a:pPr>
             <a:r>
@@ -1025,7 +1025,7 @@
                 <a:ea typeface="Calibri" pitchFamily="34" charset="-122"/>
                 <a:cs typeface="Calibri" pitchFamily="34" charset="-120"/>
               </a:rPr>
-              <a:t>SECTION</a:t>
+              <a:t>MINS</a:t>
             </a:r>
             <a:endParaRPr lang="en-US" sz="850" dirty="0"/>
           </a:p>
@@ -1039,8 +1039,8 @@
         </p:nvSpPr>
         <p:spPr>
           <a:xfrm>
-            <a:off x="5806440" y="1591056"/>
-            <a:ext cx="4526280" cy="182880"/>
+            <a:off x="1572768" y="1591056"/>
+            <a:ext cx="3291840" cy="182880"/>
           </a:xfrm>
           <a:prstGeom prst="rect">
             <a:avLst/>
@@ -1064,7 +1064,7 @@
                 <a:ea typeface="Calibri" pitchFamily="34" charset="-122"/>
                 <a:cs typeface="Calibri" pitchFamily="34" charset="-120"/>
               </a:rPr>
-              <a:t>WHAT HAPPENS</a:t>
+              <a:t>SECTION</a:t>
             </a:r>
             <a:endParaRPr lang="en-US" sz="850" dirty="0"/>
           </a:p>
@@ -1078,20 +1078,20 @@
         </p:nvSpPr>
         <p:spPr>
           <a:xfrm>
-            <a:off x="10378440" y="1591056"/>
-            <a:ext cx="1316736" cy="182880"/>
-          </a:xfrm>
-          <a:prstGeom prst="rect">
-            <a:avLst/>
-          </a:prstGeom>
-          <a:noFill/>
-          <a:ln/>
-        </p:spPr>
-        <p:txBody>
-          <a:bodyPr wrap="square" lIns="0" tIns="0" rIns="0" bIns="0" rtlCol="0" anchor="ctr"/>
-          <a:lstStyle/>
-          <a:p>
-            <a:pPr algn="r" indent="0" marL="0">
+            <a:off x="5074920" y="1591056"/>
+            <a:ext cx="6620256" cy="182880"/>
+          </a:xfrm>
+          <a:prstGeom prst="rect">
+            <a:avLst/>
+          </a:prstGeom>
+          <a:noFill/>
+          <a:ln/>
+        </p:spPr>
+        <p:txBody>
+          <a:bodyPr wrap="square" lIns="0" tIns="0" rIns="0" bIns="0" rtlCol="0" anchor="ctr"/>
+          <a:lstStyle/>
+          <a:p>
+            <a:pPr algn="l" indent="0" marL="0">
               <a:buNone/>
             </a:pPr>
             <a:r>
@@ -1103,7 +1103,7 @@
                 <a:ea typeface="Calibri" pitchFamily="34" charset="-122"/>
                 <a:cs typeface="Calibri" pitchFamily="34" charset="-120"/>
               </a:rPr>
-              <a:t>BY</a:t>
+              <a:t>WHAT WE COVER</a:t>
             </a:r>
             <a:endParaRPr lang="en-US" sz="850" dirty="0"/>
           </a:p>
@@ -1183,7 +1183,7 @@
               <a:buNone/>
             </a:pPr>
             <a:r>
-              <a:rPr lang="en-US" sz="1050" b="1" dirty="0">
+              <a:rPr lang="en-US" sz="1150" b="1" dirty="0">
                 <a:solidFill>
                   <a:srgbClr val="FFFFFF"/>
                 </a:solidFill>
@@ -1191,9 +1191,9 @@
                 <a:ea typeface="Calibri" pitchFamily="34" charset="-122"/>
                 <a:cs typeface="Calibri" pitchFamily="34" charset="-120"/>
               </a:rPr>
-              <a:t>0:40</a:t>
-            </a:r>
-            <a:endParaRPr lang="en-US" sz="1050" dirty="0"/>
+              <a:t>1</a:t>
+            </a:r>
+            <a:endParaRPr lang="en-US" sz="1150" dirty="0"/>
           </a:p>
         </p:txBody>
       </p:sp>
@@ -1206,7 +1206,7 @@
         <p:spPr>
           <a:xfrm>
             <a:off x="1572768" y="1953387"/>
-            <a:ext cx="4023360" cy="237744"/>
+            <a:ext cx="3291840" cy="237744"/>
           </a:xfrm>
           <a:prstGeom prst="rect">
             <a:avLst/>
@@ -1244,8 +1244,8 @@
         </p:nvSpPr>
         <p:spPr>
           <a:xfrm>
-            <a:off x="5806440" y="1962531"/>
-            <a:ext cx="4526280" cy="219456"/>
+            <a:off x="5074920" y="1962531"/>
+            <a:ext cx="6620256" cy="219456"/>
           </a:xfrm>
           <a:prstGeom prst="rect">
             <a:avLst/>
@@ -1277,46 +1277,7 @@
       </p:sp>
       <p:sp>
         <p:nvSpPr>
-          <p:cNvPr id="13" name="Text 11"/>
-          <p:cNvSpPr txBox="1"/>
-          <p:nvPr/>
-        </p:nvSpPr>
-        <p:spPr>
-          <a:xfrm>
-            <a:off x="10378440" y="1953387"/>
-            <a:ext cx="1316736" cy="237744"/>
-          </a:xfrm>
-          <a:prstGeom prst="rect">
-            <a:avLst/>
-          </a:prstGeom>
-          <a:noFill/>
-          <a:ln/>
-        </p:spPr>
-        <p:txBody>
-          <a:bodyPr wrap="square" lIns="0" tIns="0" rIns="0" bIns="0" rtlCol="0" anchor="ctr"/>
-          <a:lstStyle/>
-          <a:p>
-            <a:pPr algn="r" indent="0" marL="0">
-              <a:buNone/>
-            </a:pPr>
-            <a:r>
-              <a:rPr lang="en-US" sz="1250" b="1" dirty="0">
-                <a:solidFill>
-                  <a:srgbClr val="0C1E33"/>
-                </a:solidFill>
-                <a:latin typeface="Calibri" pitchFamily="34" charset="0"/>
-                <a:ea typeface="Calibri" pitchFamily="34" charset="-122"/>
-                <a:cs typeface="Calibri" pitchFamily="34" charset="-120"/>
-              </a:rPr>
-              <a:t>0:40</a:t>
-            </a:r>
-            <a:endParaRPr lang="en-US" sz="1250" dirty="0"/>
-          </a:p>
-        </p:txBody>
-      </p:sp>
-      <p:sp>
-        <p:nvSpPr>
-          <p:cNvPr id="14" name="Shape 12"/>
+          <p:cNvPr id="13" name="Shape 11"/>
           <p:cNvSpPr/>
           <p:nvPr/>
         </p:nvSpPr>
@@ -1343,7 +1304,7 @@
       </p:sp>
       <p:sp>
         <p:nvSpPr>
-          <p:cNvPr id="15" name="Shape 13"/>
+          <p:cNvPr id="14" name="Shape 12"/>
           <p:cNvSpPr/>
           <p:nvPr/>
         </p:nvSpPr>
@@ -1365,7 +1326,7 @@
       </p:sp>
       <p:sp>
         <p:nvSpPr>
-          <p:cNvPr id="16" name="Text 14"/>
+          <p:cNvPr id="15" name="Text 13"/>
           <p:cNvSpPr txBox="1"/>
           <p:nvPr/>
         </p:nvSpPr>
@@ -1388,7 +1349,7 @@
               <a:buNone/>
             </a:pPr>
             <a:r>
-              <a:rPr lang="en-US" sz="1050" b="1" dirty="0">
+              <a:rPr lang="en-US" sz="1150" b="1" dirty="0">
                 <a:solidFill>
                   <a:srgbClr val="FFFFFF"/>
                 </a:solidFill>
@@ -1396,22 +1357,22 @@
                 <a:ea typeface="Calibri" pitchFamily="34" charset="-122"/>
                 <a:cs typeface="Calibri" pitchFamily="34" charset="-120"/>
               </a:rPr>
-              <a:t>2:00</a:t>
-            </a:r>
-            <a:endParaRPr lang="en-US" sz="1050" dirty="0"/>
-          </a:p>
-        </p:txBody>
-      </p:sp>
-      <p:sp>
-        <p:nvSpPr>
-          <p:cNvPr id="17" name="Text 15"/>
+              <a:t>2</a:t>
+            </a:r>
+            <a:endParaRPr lang="en-US" sz="1150" dirty="0"/>
+          </a:p>
+        </p:txBody>
+      </p:sp>
+      <p:sp>
+        <p:nvSpPr>
+          <p:cNvPr id="16" name="Text 14"/>
           <p:cNvSpPr txBox="1"/>
           <p:nvPr/>
         </p:nvSpPr>
         <p:spPr>
           <a:xfrm>
             <a:off x="1572768" y="2513457"/>
-            <a:ext cx="4023360" cy="237744"/>
+            <a:ext cx="3291840" cy="237744"/>
           </a:xfrm>
           <a:prstGeom prst="rect">
             <a:avLst/>
@@ -1443,14 +1404,14 @@
       </p:sp>
       <p:sp>
         <p:nvSpPr>
-          <p:cNvPr id="18" name="Text 16"/>
-          <p:cNvSpPr txBox="1"/>
-          <p:nvPr/>
-        </p:nvSpPr>
-        <p:spPr>
-          <a:xfrm>
-            <a:off x="5806440" y="2522601"/>
-            <a:ext cx="4526280" cy="219456"/>
+          <p:cNvPr id="17" name="Text 15"/>
+          <p:cNvSpPr txBox="1"/>
+          <p:nvPr/>
+        </p:nvSpPr>
+        <p:spPr>
+          <a:xfrm>
+            <a:off x="5074920" y="2522601"/>
+            <a:ext cx="6620256" cy="219456"/>
           </a:xfrm>
           <a:prstGeom prst="rect">
             <a:avLst/>
@@ -1482,46 +1443,7 @@
       </p:sp>
       <p:sp>
         <p:nvSpPr>
-          <p:cNvPr id="19" name="Text 17"/>
-          <p:cNvSpPr txBox="1"/>
-          <p:nvPr/>
-        </p:nvSpPr>
-        <p:spPr>
-          <a:xfrm>
-            <a:off x="10378440" y="2513457"/>
-            <a:ext cx="1316736" cy="237744"/>
-          </a:xfrm>
-          <a:prstGeom prst="rect">
-            <a:avLst/>
-          </a:prstGeom>
-          <a:noFill/>
-          <a:ln/>
-        </p:spPr>
-        <p:txBody>
-          <a:bodyPr wrap="square" lIns="0" tIns="0" rIns="0" bIns="0" rtlCol="0" anchor="ctr"/>
-          <a:lstStyle/>
-          <a:p>
-            <a:pPr algn="r" indent="0" marL="0">
-              <a:buNone/>
-            </a:pPr>
-            <a:r>
-              <a:rPr lang="en-US" sz="1250" b="1" dirty="0">
-                <a:solidFill>
-                  <a:srgbClr val="0C1E33"/>
-                </a:solidFill>
-                <a:latin typeface="Calibri" pitchFamily="34" charset="0"/>
-                <a:ea typeface="Calibri" pitchFamily="34" charset="-122"/>
-                <a:cs typeface="Calibri" pitchFamily="34" charset="-120"/>
-              </a:rPr>
-              <a:t>2:40</a:t>
-            </a:r>
-            <a:endParaRPr lang="en-US" sz="1250" dirty="0"/>
-          </a:p>
-        </p:txBody>
-      </p:sp>
-      <p:sp>
-        <p:nvSpPr>
-          <p:cNvPr id="20" name="Shape 18"/>
+          <p:cNvPr id="18" name="Shape 16"/>
           <p:cNvSpPr/>
           <p:nvPr/>
         </p:nvSpPr>
@@ -1548,7 +1470,7 @@
       </p:sp>
       <p:sp>
         <p:nvSpPr>
-          <p:cNvPr id="21" name="Shape 19"/>
+          <p:cNvPr id="19" name="Shape 17"/>
           <p:cNvSpPr/>
           <p:nvPr/>
         </p:nvSpPr>
@@ -1570,7 +1492,7 @@
       </p:sp>
       <p:sp>
         <p:nvSpPr>
-          <p:cNvPr id="22" name="Text 20"/>
+          <p:cNvPr id="20" name="Text 18"/>
           <p:cNvSpPr txBox="1"/>
           <p:nvPr/>
         </p:nvSpPr>
@@ -1593,7 +1515,7 @@
               <a:buNone/>
             </a:pPr>
             <a:r>
-              <a:rPr lang="en-US" sz="1050" b="1" dirty="0">
+              <a:rPr lang="en-US" sz="1150" b="1" dirty="0">
                 <a:solidFill>
                   <a:srgbClr val="FFFFFF"/>
                 </a:solidFill>
@@ -1601,22 +1523,22 @@
                 <a:ea typeface="Calibri" pitchFamily="34" charset="-122"/>
                 <a:cs typeface="Calibri" pitchFamily="34" charset="-120"/>
               </a:rPr>
-              <a:t>2:20</a:t>
-            </a:r>
-            <a:endParaRPr lang="en-US" sz="1050" dirty="0"/>
-          </a:p>
-        </p:txBody>
-      </p:sp>
-      <p:sp>
-        <p:nvSpPr>
-          <p:cNvPr id="23" name="Text 21"/>
+              <a:t>2</a:t>
+            </a:r>
+            <a:endParaRPr lang="en-US" sz="1150" dirty="0"/>
+          </a:p>
+        </p:txBody>
+      </p:sp>
+      <p:sp>
+        <p:nvSpPr>
+          <p:cNvPr id="21" name="Text 19"/>
           <p:cNvSpPr txBox="1"/>
           <p:nvPr/>
         </p:nvSpPr>
         <p:spPr>
           <a:xfrm>
             <a:off x="1572768" y="3073527"/>
-            <a:ext cx="4023360" cy="237744"/>
+            <a:ext cx="3291840" cy="237744"/>
           </a:xfrm>
           <a:prstGeom prst="rect">
             <a:avLst/>
@@ -1648,14 +1570,14 @@
       </p:sp>
       <p:sp>
         <p:nvSpPr>
-          <p:cNvPr id="24" name="Text 22"/>
-          <p:cNvSpPr txBox="1"/>
-          <p:nvPr/>
-        </p:nvSpPr>
-        <p:spPr>
-          <a:xfrm>
-            <a:off x="5806440" y="3082671"/>
-            <a:ext cx="4526280" cy="219456"/>
+          <p:cNvPr id="22" name="Text 20"/>
+          <p:cNvSpPr txBox="1"/>
+          <p:nvPr/>
+        </p:nvSpPr>
+        <p:spPr>
+          <a:xfrm>
+            <a:off x="5074920" y="3082671"/>
+            <a:ext cx="6620256" cy="219456"/>
           </a:xfrm>
           <a:prstGeom prst="rect">
             <a:avLst/>
@@ -1687,46 +1609,7 @@
       </p:sp>
       <p:sp>
         <p:nvSpPr>
-          <p:cNvPr id="25" name="Text 23"/>
-          <p:cNvSpPr txBox="1"/>
-          <p:nvPr/>
-        </p:nvSpPr>
-        <p:spPr>
-          <a:xfrm>
-            <a:off x="10378440" y="3073527"/>
-            <a:ext cx="1316736" cy="237744"/>
-          </a:xfrm>
-          <a:prstGeom prst="rect">
-            <a:avLst/>
-          </a:prstGeom>
-          <a:noFill/>
-          <a:ln/>
-        </p:spPr>
-        <p:txBody>
-          <a:bodyPr wrap="square" lIns="0" tIns="0" rIns="0" bIns="0" rtlCol="0" anchor="ctr"/>
-          <a:lstStyle/>
-          <a:p>
-            <a:pPr algn="r" indent="0" marL="0">
-              <a:buNone/>
-            </a:pPr>
-            <a:r>
-              <a:rPr lang="en-US" sz="1250" b="1" dirty="0">
-                <a:solidFill>
-                  <a:srgbClr val="0C1E33"/>
-                </a:solidFill>
-                <a:latin typeface="Calibri" pitchFamily="34" charset="0"/>
-                <a:ea typeface="Calibri" pitchFamily="34" charset="-122"/>
-                <a:cs typeface="Calibri" pitchFamily="34" charset="-120"/>
-              </a:rPr>
-              <a:t>5:00</a:t>
-            </a:r>
-            <a:endParaRPr lang="en-US" sz="1250" dirty="0"/>
-          </a:p>
-        </p:txBody>
-      </p:sp>
-      <p:sp>
-        <p:nvSpPr>
-          <p:cNvPr id="26" name="Shape 24"/>
+          <p:cNvPr id="23" name="Shape 21"/>
           <p:cNvSpPr/>
           <p:nvPr/>
         </p:nvSpPr>
@@ -1753,7 +1636,7 @@
       </p:sp>
       <p:sp>
         <p:nvSpPr>
-          <p:cNvPr id="27" name="Shape 25"/>
+          <p:cNvPr id="24" name="Shape 22"/>
           <p:cNvSpPr/>
           <p:nvPr/>
         </p:nvSpPr>
@@ -1775,7 +1658,7 @@
       </p:sp>
       <p:sp>
         <p:nvSpPr>
-          <p:cNvPr id="28" name="Text 26"/>
+          <p:cNvPr id="25" name="Text 23"/>
           <p:cNvSpPr txBox="1"/>
           <p:nvPr/>
         </p:nvSpPr>
@@ -1798,7 +1681,7 @@
               <a:buNone/>
             </a:pPr>
             <a:r>
-              <a:rPr lang="en-US" sz="1050" b="1" dirty="0">
+              <a:rPr lang="en-US" sz="1150" b="1" dirty="0">
                 <a:solidFill>
                   <a:srgbClr val="FFFFFF"/>
                 </a:solidFill>
@@ -1806,22 +1689,22 @@
                 <a:ea typeface="Calibri" pitchFamily="34" charset="-122"/>
                 <a:cs typeface="Calibri" pitchFamily="34" charset="-120"/>
               </a:rPr>
-              <a:t>3:40</a:t>
-            </a:r>
-            <a:endParaRPr lang="en-US" sz="1050" dirty="0"/>
-          </a:p>
-        </p:txBody>
-      </p:sp>
-      <p:sp>
-        <p:nvSpPr>
-          <p:cNvPr id="29" name="Text 27"/>
+              <a:t>4</a:t>
+            </a:r>
+            <a:endParaRPr lang="en-US" sz="1150" dirty="0"/>
+          </a:p>
+        </p:txBody>
+      </p:sp>
+      <p:sp>
+        <p:nvSpPr>
+          <p:cNvPr id="26" name="Text 24"/>
           <p:cNvSpPr txBox="1"/>
           <p:nvPr/>
         </p:nvSpPr>
         <p:spPr>
           <a:xfrm>
             <a:off x="1572768" y="3633597"/>
-            <a:ext cx="4023360" cy="237744"/>
+            <a:ext cx="3291840" cy="237744"/>
           </a:xfrm>
           <a:prstGeom prst="rect">
             <a:avLst/>
@@ -1853,14 +1736,14 @@
       </p:sp>
       <p:sp>
         <p:nvSpPr>
-          <p:cNvPr id="30" name="Text 28"/>
-          <p:cNvSpPr txBox="1"/>
-          <p:nvPr/>
-        </p:nvSpPr>
-        <p:spPr>
-          <a:xfrm>
-            <a:off x="5806440" y="3642741"/>
-            <a:ext cx="4526280" cy="219456"/>
+          <p:cNvPr id="27" name="Text 25"/>
+          <p:cNvSpPr txBox="1"/>
+          <p:nvPr/>
+        </p:nvSpPr>
+        <p:spPr>
+          <a:xfrm>
+            <a:off x="5074920" y="3642741"/>
+            <a:ext cx="6620256" cy="219456"/>
           </a:xfrm>
           <a:prstGeom prst="rect">
             <a:avLst/>
@@ -1892,46 +1775,7 @@
       </p:sp>
       <p:sp>
         <p:nvSpPr>
-          <p:cNvPr id="31" name="Text 29"/>
-          <p:cNvSpPr txBox="1"/>
-          <p:nvPr/>
-        </p:nvSpPr>
-        <p:spPr>
-          <a:xfrm>
-            <a:off x="10378440" y="3633597"/>
-            <a:ext cx="1316736" cy="237744"/>
-          </a:xfrm>
-          <a:prstGeom prst="rect">
-            <a:avLst/>
-          </a:prstGeom>
-          <a:noFill/>
-          <a:ln/>
-        </p:spPr>
-        <p:txBody>
-          <a:bodyPr wrap="square" lIns="0" tIns="0" rIns="0" bIns="0" rtlCol="0" anchor="ctr"/>
-          <a:lstStyle/>
-          <a:p>
-            <a:pPr algn="r" indent="0" marL="0">
-              <a:buNone/>
-            </a:pPr>
-            <a:r>
-              <a:rPr lang="en-US" sz="1250" b="1" dirty="0">
-                <a:solidFill>
-                  <a:srgbClr val="0C1E33"/>
-                </a:solidFill>
-                <a:latin typeface="Calibri" pitchFamily="34" charset="0"/>
-                <a:ea typeface="Calibri" pitchFamily="34" charset="-122"/>
-                <a:cs typeface="Calibri" pitchFamily="34" charset="-120"/>
-              </a:rPr>
-              <a:t>8:40</a:t>
-            </a:r>
-            <a:endParaRPr lang="en-US" sz="1250" dirty="0"/>
-          </a:p>
-        </p:txBody>
-      </p:sp>
-      <p:sp>
-        <p:nvSpPr>
-          <p:cNvPr id="32" name="Shape 30"/>
+          <p:cNvPr id="28" name="Shape 26"/>
           <p:cNvSpPr/>
           <p:nvPr/>
         </p:nvSpPr>
@@ -1958,7 +1802,7 @@
       </p:sp>
       <p:sp>
         <p:nvSpPr>
-          <p:cNvPr id="33" name="Shape 31"/>
+          <p:cNvPr id="29" name="Shape 27"/>
           <p:cNvSpPr/>
           <p:nvPr/>
         </p:nvSpPr>
@@ -1980,7 +1824,7 @@
       </p:sp>
       <p:sp>
         <p:nvSpPr>
-          <p:cNvPr id="34" name="Text 32"/>
+          <p:cNvPr id="30" name="Text 28"/>
           <p:cNvSpPr txBox="1"/>
           <p:nvPr/>
         </p:nvSpPr>
@@ -2003,7 +1847,7 @@
               <a:buNone/>
             </a:pPr>
             <a:r>
-              <a:rPr lang="en-US" sz="1050" b="1" dirty="0">
+              <a:rPr lang="en-US" sz="1150" b="1" dirty="0">
                 <a:solidFill>
                   <a:srgbClr val="FFFFFF"/>
                 </a:solidFill>
@@ -2011,22 +1855,22 @@
                 <a:ea typeface="Calibri" pitchFamily="34" charset="-122"/>
                 <a:cs typeface="Calibri" pitchFamily="34" charset="-120"/>
               </a:rPr>
-              <a:t>2:20</a:t>
-            </a:r>
-            <a:endParaRPr lang="en-US" sz="1050" dirty="0"/>
-          </a:p>
-        </p:txBody>
-      </p:sp>
-      <p:sp>
-        <p:nvSpPr>
-          <p:cNvPr id="35" name="Text 33"/>
+              <a:t>2</a:t>
+            </a:r>
+            <a:endParaRPr lang="en-US" sz="1150" dirty="0"/>
+          </a:p>
+        </p:txBody>
+      </p:sp>
+      <p:sp>
+        <p:nvSpPr>
+          <p:cNvPr id="31" name="Text 29"/>
           <p:cNvSpPr txBox="1"/>
           <p:nvPr/>
         </p:nvSpPr>
         <p:spPr>
           <a:xfrm>
             <a:off x="1572768" y="4193667"/>
-            <a:ext cx="4023360" cy="237744"/>
+            <a:ext cx="3291840" cy="237744"/>
           </a:xfrm>
           <a:prstGeom prst="rect">
             <a:avLst/>
@@ -2058,14 +1902,14 @@
       </p:sp>
       <p:sp>
         <p:nvSpPr>
-          <p:cNvPr id="36" name="Text 34"/>
-          <p:cNvSpPr txBox="1"/>
-          <p:nvPr/>
-        </p:nvSpPr>
-        <p:spPr>
-          <a:xfrm>
-            <a:off x="5806440" y="4202811"/>
-            <a:ext cx="4526280" cy="219456"/>
+          <p:cNvPr id="32" name="Text 30"/>
+          <p:cNvSpPr txBox="1"/>
+          <p:nvPr/>
+        </p:nvSpPr>
+        <p:spPr>
+          <a:xfrm>
+            <a:off x="5074920" y="4202811"/>
+            <a:ext cx="6620256" cy="219456"/>
           </a:xfrm>
           <a:prstGeom prst="rect">
             <a:avLst/>
@@ -2097,46 +1941,7 @@
       </p:sp>
       <p:sp>
         <p:nvSpPr>
-          <p:cNvPr id="37" name="Text 35"/>
-          <p:cNvSpPr txBox="1"/>
-          <p:nvPr/>
-        </p:nvSpPr>
-        <p:spPr>
-          <a:xfrm>
-            <a:off x="10378440" y="4193667"/>
-            <a:ext cx="1316736" cy="237744"/>
-          </a:xfrm>
-          <a:prstGeom prst="rect">
-            <a:avLst/>
-          </a:prstGeom>
-          <a:noFill/>
-          <a:ln/>
-        </p:spPr>
-        <p:txBody>
-          <a:bodyPr wrap="square" lIns="0" tIns="0" rIns="0" bIns="0" rtlCol="0" anchor="ctr"/>
-          <a:lstStyle/>
-          <a:p>
-            <a:pPr algn="r" indent="0" marL="0">
-              <a:buNone/>
-            </a:pPr>
-            <a:r>
-              <a:rPr lang="en-US" sz="1250" b="1" dirty="0">
-                <a:solidFill>
-                  <a:srgbClr val="0C1E33"/>
-                </a:solidFill>
-                <a:latin typeface="Calibri" pitchFamily="34" charset="0"/>
-                <a:ea typeface="Calibri" pitchFamily="34" charset="-122"/>
-                <a:cs typeface="Calibri" pitchFamily="34" charset="-120"/>
-              </a:rPr>
-              <a:t>11:00</a:t>
-            </a:r>
-            <a:endParaRPr lang="en-US" sz="1250" dirty="0"/>
-          </a:p>
-        </p:txBody>
-      </p:sp>
-      <p:sp>
-        <p:nvSpPr>
-          <p:cNvPr id="38" name="Shape 36"/>
+          <p:cNvPr id="33" name="Shape 31"/>
           <p:cNvSpPr/>
           <p:nvPr/>
         </p:nvSpPr>
@@ -2163,7 +1968,7 @@
       </p:sp>
       <p:sp>
         <p:nvSpPr>
-          <p:cNvPr id="39" name="Shape 37"/>
+          <p:cNvPr id="34" name="Shape 32"/>
           <p:cNvSpPr/>
           <p:nvPr/>
         </p:nvSpPr>
@@ -2185,7 +1990,7 @@
       </p:sp>
       <p:sp>
         <p:nvSpPr>
-          <p:cNvPr id="40" name="Text 38"/>
+          <p:cNvPr id="35" name="Text 33"/>
           <p:cNvSpPr txBox="1"/>
           <p:nvPr/>
         </p:nvSpPr>
@@ -2208,7 +2013,7 @@
               <a:buNone/>
             </a:pPr>
             <a:r>
-              <a:rPr lang="en-US" sz="1050" b="1" dirty="0">
+              <a:rPr lang="en-US" sz="1150" b="1" dirty="0">
                 <a:solidFill>
                   <a:srgbClr val="FFFFFF"/>
                 </a:solidFill>
@@ -2216,22 +2021,22 @@
                 <a:ea typeface="Calibri" pitchFamily="34" charset="-122"/>
                 <a:cs typeface="Calibri" pitchFamily="34" charset="-120"/>
               </a:rPr>
-              <a:t>3:30</a:t>
-            </a:r>
-            <a:endParaRPr lang="en-US" sz="1050" dirty="0"/>
-          </a:p>
-        </p:txBody>
-      </p:sp>
-      <p:sp>
-        <p:nvSpPr>
-          <p:cNvPr id="41" name="Text 39"/>
+              <a:t>3</a:t>
+            </a:r>
+            <a:endParaRPr lang="en-US" sz="1150" dirty="0"/>
+          </a:p>
+        </p:txBody>
+      </p:sp>
+      <p:sp>
+        <p:nvSpPr>
+          <p:cNvPr id="36" name="Text 34"/>
           <p:cNvSpPr txBox="1"/>
           <p:nvPr/>
         </p:nvSpPr>
         <p:spPr>
           <a:xfrm>
             <a:off x="1572768" y="4753737"/>
-            <a:ext cx="4023360" cy="237744"/>
+            <a:ext cx="3291840" cy="237744"/>
           </a:xfrm>
           <a:prstGeom prst="rect">
             <a:avLst/>
@@ -2263,14 +2068,14 @@
       </p:sp>
       <p:sp>
         <p:nvSpPr>
-          <p:cNvPr id="42" name="Text 40"/>
-          <p:cNvSpPr txBox="1"/>
-          <p:nvPr/>
-        </p:nvSpPr>
-        <p:spPr>
-          <a:xfrm>
-            <a:off x="5806440" y="4762881"/>
-            <a:ext cx="4526280" cy="219456"/>
+          <p:cNvPr id="37" name="Text 35"/>
+          <p:cNvSpPr txBox="1"/>
+          <p:nvPr/>
+        </p:nvSpPr>
+        <p:spPr>
+          <a:xfrm>
+            <a:off x="5074920" y="4762881"/>
+            <a:ext cx="6620256" cy="219456"/>
           </a:xfrm>
           <a:prstGeom prst="rect">
             <a:avLst/>
@@ -2294,7 +2099,7 @@
                 <a:ea typeface="Calibri" pitchFamily="34" charset="-122"/>
                 <a:cs typeface="Calibri" pitchFamily="34" charset="-120"/>
               </a:rPr>
-              <a:t>Country packs, permit types, the clinician second licence.</a:t>
+              <a:t>Country packs, permit types, and the second licence a clinician needs.</a:t>
             </a:r>
             <a:endParaRPr lang="en-US" sz="940" dirty="0"/>
           </a:p>
@@ -2302,46 +2107,7 @@
       </p:sp>
       <p:sp>
         <p:nvSpPr>
-          <p:cNvPr id="43" name="Text 41"/>
-          <p:cNvSpPr txBox="1"/>
-          <p:nvPr/>
-        </p:nvSpPr>
-        <p:spPr>
-          <a:xfrm>
-            <a:off x="10378440" y="4753737"/>
-            <a:ext cx="1316736" cy="237744"/>
-          </a:xfrm>
-          <a:prstGeom prst="rect">
-            <a:avLst/>
-          </a:prstGeom>
-          <a:noFill/>
-          <a:ln/>
-        </p:spPr>
-        <p:txBody>
-          <a:bodyPr wrap="square" lIns="0" tIns="0" rIns="0" bIns="0" rtlCol="0" anchor="ctr"/>
-          <a:lstStyle/>
-          <a:p>
-            <a:pPr algn="r" indent="0" marL="0">
-              <a:buNone/>
-            </a:pPr>
-            <a:r>
-              <a:rPr lang="en-US" sz="1250" b="1" dirty="0">
-                <a:solidFill>
-                  <a:srgbClr val="0C1E33"/>
-                </a:solidFill>
-                <a:latin typeface="Calibri" pitchFamily="34" charset="0"/>
-                <a:ea typeface="Calibri" pitchFamily="34" charset="-122"/>
-                <a:cs typeface="Calibri" pitchFamily="34" charset="-120"/>
-              </a:rPr>
-              <a:t>14:30</a:t>
-            </a:r>
-            <a:endParaRPr lang="en-US" sz="1250" dirty="0"/>
-          </a:p>
-        </p:txBody>
-      </p:sp>
-      <p:sp>
-        <p:nvSpPr>
-          <p:cNvPr id="44" name="Shape 42"/>
+          <p:cNvPr id="38" name="Shape 36"/>
           <p:cNvSpPr/>
           <p:nvPr/>
         </p:nvSpPr>
@@ -2368,7 +2134,7 @@
       </p:sp>
       <p:sp>
         <p:nvSpPr>
-          <p:cNvPr id="45" name="Shape 43"/>
+          <p:cNvPr id="39" name="Shape 37"/>
           <p:cNvSpPr/>
           <p:nvPr/>
         </p:nvSpPr>
@@ -2390,7 +2156,7 @@
       </p:sp>
       <p:sp>
         <p:nvSpPr>
-          <p:cNvPr id="46" name="Text 44"/>
+          <p:cNvPr id="40" name="Text 38"/>
           <p:cNvSpPr txBox="1"/>
           <p:nvPr/>
         </p:nvSpPr>
@@ -2413,7 +2179,7 @@
               <a:buNone/>
             </a:pPr>
             <a:r>
-              <a:rPr lang="en-US" sz="1050" b="1" dirty="0">
+              <a:rPr lang="en-US" sz="1150" b="1" dirty="0">
                 <a:solidFill>
                   <a:srgbClr val="FFFFFF"/>
                 </a:solidFill>
@@ -2421,22 +2187,22 @@
                 <a:ea typeface="Calibri" pitchFamily="34" charset="-122"/>
                 <a:cs typeface="Calibri" pitchFamily="34" charset="-120"/>
               </a:rPr>
-              <a:t>3:30</a:t>
-            </a:r>
-            <a:endParaRPr lang="en-US" sz="1050" dirty="0"/>
-          </a:p>
-        </p:txBody>
-      </p:sp>
-      <p:sp>
-        <p:nvSpPr>
-          <p:cNvPr id="47" name="Text 45"/>
+              <a:t>4</a:t>
+            </a:r>
+            <a:endParaRPr lang="en-US" sz="1150" dirty="0"/>
+          </a:p>
+        </p:txBody>
+      </p:sp>
+      <p:sp>
+        <p:nvSpPr>
+          <p:cNvPr id="41" name="Text 39"/>
           <p:cNvSpPr txBox="1"/>
           <p:nvPr/>
         </p:nvSpPr>
         <p:spPr>
           <a:xfrm>
             <a:off x="1572768" y="5313807"/>
-            <a:ext cx="4023360" cy="237744"/>
+            <a:ext cx="3291840" cy="237744"/>
           </a:xfrm>
           <a:prstGeom prst="rect">
             <a:avLst/>
@@ -2468,14 +2234,14 @@
       </p:sp>
       <p:sp>
         <p:nvSpPr>
-          <p:cNvPr id="48" name="Text 46"/>
-          <p:cNvSpPr txBox="1"/>
-          <p:nvPr/>
-        </p:nvSpPr>
-        <p:spPr>
-          <a:xfrm>
-            <a:off x="5806440" y="5322951"/>
-            <a:ext cx="4526280" cy="219456"/>
+          <p:cNvPr id="42" name="Text 40"/>
+          <p:cNvSpPr txBox="1"/>
+          <p:nvPr/>
+        </p:nvSpPr>
+        <p:spPr>
+          <a:xfrm>
+            <a:off x="5074920" y="5322951"/>
+            <a:ext cx="6620256" cy="219456"/>
           </a:xfrm>
           <a:prstGeom prst="rect">
             <a:avLst/>
@@ -2499,7 +2265,7 @@
                 <a:ea typeface="Calibri" pitchFamily="34" charset="-122"/>
                 <a:cs typeface="Calibri" pitchFamily="34" charset="-120"/>
               </a:rPr>
-              <a:t>Where we sit between government and SuccessFactors.</a:t>
+              <a:t>Where we sit between the government portals and SuccessFactors.</a:t>
             </a:r>
             <a:endParaRPr lang="en-US" sz="940" dirty="0"/>
           </a:p>
@@ -2507,46 +2273,7 @@
       </p:sp>
       <p:sp>
         <p:nvSpPr>
-          <p:cNvPr id="49" name="Text 47"/>
-          <p:cNvSpPr txBox="1"/>
-          <p:nvPr/>
-        </p:nvSpPr>
-        <p:spPr>
-          <a:xfrm>
-            <a:off x="10378440" y="5313807"/>
-            <a:ext cx="1316736" cy="237744"/>
-          </a:xfrm>
-          <a:prstGeom prst="rect">
-            <a:avLst/>
-          </a:prstGeom>
-          <a:noFill/>
-          <a:ln/>
-        </p:spPr>
-        <p:txBody>
-          <a:bodyPr wrap="square" lIns="0" tIns="0" rIns="0" bIns="0" rtlCol="0" anchor="ctr"/>
-          <a:lstStyle/>
-          <a:p>
-            <a:pPr algn="r" indent="0" marL="0">
-              <a:buNone/>
-            </a:pPr>
-            <a:r>
-              <a:rPr lang="en-US" sz="1250" b="1" dirty="0">
-                <a:solidFill>
-                  <a:srgbClr val="0C1E33"/>
-                </a:solidFill>
-                <a:latin typeface="Calibri" pitchFamily="34" charset="0"/>
-                <a:ea typeface="Calibri" pitchFamily="34" charset="-122"/>
-                <a:cs typeface="Calibri" pitchFamily="34" charset="-120"/>
-              </a:rPr>
-              <a:t>18:00</a:t>
-            </a:r>
-            <a:endParaRPr lang="en-US" sz="1250" dirty="0"/>
-          </a:p>
-        </p:txBody>
-      </p:sp>
-      <p:sp>
-        <p:nvSpPr>
-          <p:cNvPr id="50" name="Shape 48"/>
+          <p:cNvPr id="43" name="Shape 41"/>
           <p:cNvSpPr/>
           <p:nvPr/>
         </p:nvSpPr>
@@ -2573,7 +2300,7 @@
       </p:sp>
       <p:sp>
         <p:nvSpPr>
-          <p:cNvPr id="51" name="Shape 49"/>
+          <p:cNvPr id="44" name="Shape 42"/>
           <p:cNvSpPr/>
           <p:nvPr/>
         </p:nvSpPr>
@@ -2595,7 +2322,7 @@
       </p:sp>
       <p:sp>
         <p:nvSpPr>
-          <p:cNvPr id="52" name="Text 50"/>
+          <p:cNvPr id="45" name="Text 43"/>
           <p:cNvSpPr txBox="1"/>
           <p:nvPr/>
         </p:nvSpPr>
@@ -2618,7 +2345,7 @@
               <a:buNone/>
             </a:pPr>
             <a:r>
-              <a:rPr lang="en-US" sz="1050" b="1" dirty="0">
+              <a:rPr lang="en-US" sz="1150" b="1" dirty="0">
                 <a:solidFill>
                   <a:srgbClr val="FFFFFF"/>
                 </a:solidFill>
@@ -2626,22 +2353,22 @@
                 <a:ea typeface="Calibri" pitchFamily="34" charset="-122"/>
                 <a:cs typeface="Calibri" pitchFamily="34" charset="-120"/>
               </a:rPr>
-              <a:t>2:00</a:t>
-            </a:r>
-            <a:endParaRPr lang="en-US" sz="1050" dirty="0"/>
-          </a:p>
-        </p:txBody>
-      </p:sp>
-      <p:sp>
-        <p:nvSpPr>
-          <p:cNvPr id="53" name="Text 51"/>
+              <a:t>2</a:t>
+            </a:r>
+            <a:endParaRPr lang="en-US" sz="1150" dirty="0"/>
+          </a:p>
+        </p:txBody>
+      </p:sp>
+      <p:sp>
+        <p:nvSpPr>
+          <p:cNvPr id="46" name="Text 44"/>
           <p:cNvSpPr txBox="1"/>
           <p:nvPr/>
         </p:nvSpPr>
         <p:spPr>
           <a:xfrm>
             <a:off x="1572768" y="5873877"/>
-            <a:ext cx="4023360" cy="237744"/>
+            <a:ext cx="3291840" cy="237744"/>
           </a:xfrm>
           <a:prstGeom prst="rect">
             <a:avLst/>
@@ -2673,14 +2400,14 @@
       </p:sp>
       <p:sp>
         <p:nvSpPr>
-          <p:cNvPr id="54" name="Text 52"/>
-          <p:cNvSpPr txBox="1"/>
-          <p:nvPr/>
-        </p:nvSpPr>
-        <p:spPr>
-          <a:xfrm>
-            <a:off x="5806440" y="5883021"/>
-            <a:ext cx="4526280" cy="219456"/>
+          <p:cNvPr id="47" name="Text 45"/>
+          <p:cNvSpPr txBox="1"/>
+          <p:nvPr/>
+        </p:nvSpPr>
+        <p:spPr>
+          <a:xfrm>
+            <a:off x="5074920" y="5883021"/>
+            <a:ext cx="6620256" cy="219456"/>
           </a:xfrm>
           <a:prstGeom prst="rect">
             <a:avLst/>
@@ -2704,7 +2431,7 @@
                 <a:ea typeface="Calibri" pitchFamily="34" charset="-122"/>
                 <a:cs typeface="Calibri" pitchFamily="34" charset="-120"/>
               </a:rPr>
-              <a:t>The BTP services you provision, and what happens after today.</a:t>
+              <a:t>The SAP BTP services you provision, and what happens after today.</a:t>
             </a:r>
             <a:endParaRPr lang="en-US" sz="940" dirty="0"/>
           </a:p>
@@ -2712,116 +2439,77 @@
       </p:sp>
       <p:sp>
         <p:nvSpPr>
-          <p:cNvPr id="55" name="Text 53"/>
-          <p:cNvSpPr txBox="1"/>
-          <p:nvPr/>
-        </p:nvSpPr>
-        <p:spPr>
-          <a:xfrm>
-            <a:off x="10378440" y="5873877"/>
-            <a:ext cx="1316736" cy="237744"/>
-          </a:xfrm>
-          <a:prstGeom prst="rect">
-            <a:avLst/>
-          </a:prstGeom>
-          <a:noFill/>
-          <a:ln/>
-        </p:spPr>
-        <p:txBody>
-          <a:bodyPr wrap="square" lIns="0" tIns="0" rIns="0" bIns="0" rtlCol="0" anchor="ctr"/>
-          <a:lstStyle/>
-          <a:p>
-            <a:pPr algn="r" indent="0" marL="0">
-              <a:buNone/>
-            </a:pPr>
-            <a:r>
-              <a:rPr lang="en-US" sz="1250" b="1" dirty="0">
-                <a:solidFill>
-                  <a:srgbClr val="12756F"/>
+          <p:cNvPr id="48" name="Text 46"/>
+          <p:cNvSpPr txBox="1"/>
+          <p:nvPr/>
+        </p:nvSpPr>
+        <p:spPr>
+          <a:xfrm>
+            <a:off x="548640" y="6419088"/>
+            <a:ext cx="8595360" cy="237744"/>
+          </a:xfrm>
+          <a:prstGeom prst="rect">
+            <a:avLst/>
+          </a:prstGeom>
+          <a:noFill/>
+          <a:ln/>
+        </p:spPr>
+        <p:txBody>
+          <a:bodyPr wrap="square" lIns="0" tIns="0" rIns="0" bIns="0" rtlCol="0" anchor="ctr"/>
+          <a:lstStyle/>
+          <a:p>
+            <a:pPr indent="0" marL="0">
+              <a:buNone/>
+            </a:pPr>
+            <a:r>
+              <a:rPr lang="en-US" sz="900" dirty="0">
+                <a:solidFill>
+                  <a:srgbClr val="96A3AE"/>
                 </a:solidFill>
                 <a:latin typeface="Calibri" pitchFamily="34" charset="0"/>
                 <a:ea typeface="Calibri" pitchFamily="34" charset="-122"/>
                 <a:cs typeface="Calibri" pitchFamily="34" charset="-120"/>
               </a:rPr>
-              <a:t>20:00</a:t>
-            </a:r>
-            <a:endParaRPr lang="en-US" sz="1250" dirty="0"/>
-          </a:p>
-        </p:txBody>
-      </p:sp>
-      <p:sp>
-        <p:nvSpPr>
-          <p:cNvPr id="56" name="Text 54"/>
-          <p:cNvSpPr txBox="1"/>
-          <p:nvPr/>
-        </p:nvSpPr>
-        <p:spPr>
-          <a:xfrm>
-            <a:off x="548640" y="6419088"/>
-            <a:ext cx="8595360" cy="237744"/>
-          </a:xfrm>
-          <a:prstGeom prst="rect">
-            <a:avLst/>
-          </a:prstGeom>
-          <a:noFill/>
-          <a:ln/>
-        </p:spPr>
-        <p:txBody>
-          <a:bodyPr wrap="square" lIns="0" tIns="0" rIns="0" bIns="0" rtlCol="0" anchor="ctr"/>
-          <a:lstStyle/>
-          <a:p>
-            <a:pPr indent="0" marL="0">
-              <a:buNone/>
-            </a:pPr>
-            <a:r>
-              <a:rPr lang="en-US" sz="900" dirty="0">
-                <a:solidFill>
-                  <a:srgbClr val="96A3AE"/>
+              <a:t>INK IT Business Solutions  ·  Visa &amp; Permits Management  ·  GCC</a:t>
+            </a:r>
+            <a:endParaRPr lang="en-US" sz="900" dirty="0"/>
+          </a:p>
+        </p:txBody>
+      </p:sp>
+      <p:sp>
+        <p:nvSpPr>
+          <p:cNvPr id="49" name="Text 47"/>
+          <p:cNvSpPr txBox="1"/>
+          <p:nvPr/>
+        </p:nvSpPr>
+        <p:spPr>
+          <a:xfrm>
+            <a:off x="10058400" y="6419088"/>
+            <a:ext cx="1636776" cy="237744"/>
+          </a:xfrm>
+          <a:prstGeom prst="rect">
+            <a:avLst/>
+          </a:prstGeom>
+          <a:noFill/>
+          <a:ln/>
+        </p:spPr>
+        <p:txBody>
+          <a:bodyPr wrap="square" lIns="0" tIns="0" rIns="0" bIns="0" rtlCol="0" anchor="ctr"/>
+          <a:lstStyle/>
+          <a:p>
+            <a:pPr algn="r" indent="0" marL="0">
+              <a:buNone/>
+            </a:pPr>
+            <a:r>
+              <a:rPr lang="en-US" sz="900" b="1" spc="120" kern="0" dirty="0">
+                <a:solidFill>
+                  <a:srgbClr val="C9A227"/>
                 </a:solidFill>
                 <a:latin typeface="Calibri" pitchFamily="34" charset="0"/>
                 <a:ea typeface="Calibri" pitchFamily="34" charset="-122"/>
                 <a:cs typeface="Calibri" pitchFamily="34" charset="-120"/>
               </a:rPr>
-              <a:t>INK IT Business Solutions  ·  Visa &amp; Permits Management  ·  GCC</a:t>
-            </a:r>
-            <a:endParaRPr lang="en-US" sz="900" dirty="0"/>
-          </a:p>
-        </p:txBody>
-      </p:sp>
-      <p:sp>
-        <p:nvSpPr>
-          <p:cNvPr id="57" name="Text 55"/>
-          <p:cNvSpPr txBox="1"/>
-          <p:nvPr/>
-        </p:nvSpPr>
-        <p:spPr>
-          <a:xfrm>
-            <a:off x="10881360" y="6419088"/>
-            <a:ext cx="813816" cy="237744"/>
-          </a:xfrm>
-          <a:prstGeom prst="rect">
-            <a:avLst/>
-          </a:prstGeom>
-          <a:noFill/>
-          <a:ln/>
-        </p:spPr>
-        <p:txBody>
-          <a:bodyPr wrap="square" lIns="0" tIns="0" rIns="0" bIns="0" rtlCol="0" anchor="ctr"/>
-          <a:lstStyle/>
-          <a:p>
-            <a:pPr algn="r" indent="0" marL="0">
-              <a:buNone/>
-            </a:pPr>
-            <a:r>
-              <a:rPr lang="en-US" sz="900" b="1" dirty="0">
-                <a:solidFill>
-                  <a:srgbClr val="C9A227"/>
-                </a:solidFill>
-                <a:latin typeface="Calibri" pitchFamily="34" charset="0"/>
-                <a:ea typeface="Calibri" pitchFamily="34" charset="-122"/>
-                <a:cs typeface="Calibri" pitchFamily="34" charset="-120"/>
-              </a:rPr>
-              <a:t>20:00</a:t>
+              <a:t>20 MINUTES</a:t>
             </a:r>
             <a:endParaRPr lang="en-US" sz="900" dirty="0"/>
           </a:p>

</xml_diff>